<commit_message>
Final Submission: Optimized 0.5M parameter CNN, CIFAR-10 validation, and ResNet50 Transfer Learning results
</commit_message>
<xml_diff>
--- a/תרגיל-1 למיד עמוקה.pptx
+++ b/תרגיל-1 למיד עמוקה.pptx
@@ -6740,7 +6740,13 @@
               <a:buNone/>
             </a:pPr>
             <a:r>
-              <a:t/>
+              <a:rPr lang="iw" u="sng">
+                <a:solidFill>
+                  <a:schemeClr val="hlink"/>
+                </a:solidFill>
+                <a:hlinkClick r:id="rId3"/>
+              </a:rPr>
+              <a:t>קישור ל GITHUB</a:t>
             </a:r>
             <a:endParaRPr/>
           </a:p>
@@ -10027,7 +10033,7 @@
             <a:tbl>
               <a:tblPr>
                 <a:noFill/>
-                <a:tableStyleId>{BC5950FB-2012-429C-A80B-38DA7BFAC2C0}</a:tableStyleId>
+                <a:tableStyleId>{A9FF8C94-7492-4D9E-89F0-A9AF8F00EA0E}</a:tableStyleId>
               </a:tblPr>
               <a:tblGrid>
                 <a:gridCol w="1447800"/>

</xml_diff>